<commit_message>
feat: Noite 8 refeita - Configurando o roteador (sai o planejamento da rede de casa)
O planejamento (planta, orçamento, medição de cabo) já foi trabalhado em outras
noites. A Noite 8 passa a ser a configuração completa do roteador, da caixa à
ficha de entrega. Noite 7 com a tarefa trocada (etiqueta do roteador de casa) e
referências às noites seguintes renumeradas; Plano Mensal 3 atualizado.

Co-Authored-By: Claude Opus 5.5 <noreply@anthropic.com>
Claude-Session: https://claude.ai/code/session_01WrXN2ywUtqvw4LjCuXr4xk
</commit_message>
<xml_diff>
--- a/Aula - Redes 7 - Nomes na rede.pptx
+++ b/Aula - Redes 7 - Nomes na rede.pptx
@@ -9178,7 +9178,7 @@
                   <a:srgbClr val="0B5C5C"/>
                 </a:solidFill>
               </a:rPr>
-              <a:t>Planejando a rede de uma casa</a:t>
+              <a:t>Configurando o roteador</a:t>
             </a:r>
           </a:p>
         </p:txBody>
@@ -9277,7 +9277,7 @@
                   <a:srgbClr val="1A1A1A"/>
                 </a:solidFill>
               </a:rPr>
-              <a:t>•  Desenhe a planta da sua casa à mão, vista de cima</a:t>
+              <a:t>•  Anote a marca e o modelo do roteador de casa (etiqueta embaixo)</a:t>
             </a:r>
           </a:p>
           <a:p>
@@ -9288,7 +9288,7 @@
                   <a:srgbClr val="1A1A1A"/>
                 </a:solidFill>
               </a:rPr>
-              <a:t>•  X onde fica o modem ou roteador</a:t>
+              <a:t>•  O nome do Wi-Fi da casa é igual ao da etiqueta?</a:t>
             </a:r>
           </a:p>
           <a:p>
@@ -9299,18 +9299,7 @@
                   <a:srgbClr val="1A1A1A"/>
                 </a:solidFill>
               </a:rPr>
-              <a:t>•  Uma seta por onde o cabo da internet chega</a:t>
-            </a:r>
-          </a:p>
-          <a:p>
-            <a:pPr algn="l"/>
-            <a:r>
-              <a:rPr sz="2000" b="0" i="0">
-                <a:solidFill>
-                  <a:srgbClr val="1A1A1A"/>
-                </a:solidFill>
-              </a:rPr>
-              <a:t>•  Pinte os cômodos onde o Wi-Fi é fraco</a:t>
+              <a:t>•  Alguém em casa sabe a senha de administrador?</a:t>
             </a:r>
           </a:p>
         </p:txBody>
@@ -9318,6 +9307,40 @@
       <p:sp>
         <p:nvSpPr>
           <p:cNvPr id="7" name="TextBox 6"/>
+          <p:cNvSpPr txBox="1"/>
+          <p:nvPr/>
+        </p:nvSpPr>
+        <p:spPr>
+          <a:xfrm>
+            <a:off x="640080" y="5852160"/>
+            <a:ext cx="10881360" cy="457200"/>
+          </a:xfrm>
+          <a:prstGeom prst="rect">
+            <a:avLst/>
+          </a:prstGeom>
+          <a:noFill/>
+        </p:spPr>
+        <p:txBody>
+          <a:bodyPr wrap="square" lIns="0" rIns="0" tIns="0" bIns="0" anchor="t">
+            <a:spAutoFit/>
+          </a:bodyPr>
+          <a:lstStyle/>
+          <a:p>
+            <a:pPr algn="ctr"/>
+            <a:r>
+              <a:rPr sz="1600" b="0" i="1">
+                <a:solidFill>
+                  <a:srgbClr val="C5362B"/>
+                </a:solidFill>
+              </a:rPr>
+              <a:t>Não tire foto da etiqueta nem mande a senha pra ninguém.</a:t>
+            </a:r>
+          </a:p>
+        </p:txBody>
+      </p:sp>
+      <p:sp>
+        <p:nvSpPr>
+          <p:cNvPr id="8" name="TextBox 7"/>
           <p:cNvSpPr txBox="1"/>
           <p:nvPr/>
         </p:nvSpPr>
@@ -10729,7 +10752,7 @@
                   <a:srgbClr val="1A1A1A"/>
                 </a:solidFill>
               </a:rPr>
-              <a:t>•  Na Noite 9 a gente vê onde se troca a agenda do roteador</a:t>
+              <a:t>•  Na Noite 8 a gente vê onde se troca a agenda do roteador</a:t>
             </a:r>
           </a:p>
         </p:txBody>

</xml_diff>